<commit_message>
docs: one administrator, with a password (#99, task 5)
The plan and guide pages that described the two-person rules now describe
the password step, the audit log and ghost detection as the safeguard, keep
the old rule as dated history, and the defence answer reads: any admin can
act, but sensitive actions need their password, everything is in the audit
log, and ghost detection still flags suspicious patterns. The defence deck
says the same on slides 3, 5 and 10, with current test numbers.
</commit_message>
<xml_diff>
--- a/docs/guides/SAMTEC-defence-slides.pptx
+++ b/docs/guides/SAMTEC-defence-slides.pptx
@@ -605,7 +605,7 @@
           <a:p>
             <a:r>
               <a:rPr lang="en-US" dirty="0"/>
-              <a:t>I prepared this run, so the system will not let me approve it. A different person must. DO: approve as the second account. The moment it is approved it locks; the database refuses any change to the figures from now on, and the payslip PDF is written in the same transaction, so what was sent is exactly what exists. DO: open a payslip PDF, show the bank file.</a:t>
+              <a:t>I prepared this run, and I may approve it myself. The system asks for my password first, and writes the approval to the audit log with my name. DO: approve, type the password. The moment it is approved it locks; the database refuses any change to the figures from now on, and the payslip PDF is written in the same transaction, so what was sent is exactly what exists. DO: open a payslip PDF, show the bank file.</a:t>
             </a:r>
             <a:endParaRPr lang="en-US" dirty="0"/>
           </a:p>
@@ -781,7 +781,7 @@
           <a:p>
             <a:r>
               <a:rPr lang="en-US" dirty="0"/>
-              <a:t>Over fourteen hundred automated checks run on every change: 897 on the API, 383 on the dashboard, 106 on the kiosk, 35 on the gateway, including money calculated to the pesewa against payslips we worked by hand, and database rules proved against a real PostgreSQL. Every phase went through four reviews, and each serious finding was handed to a sceptic told to refute it. The whole-system review found twenty real problems; three were serious; all twenty are fixed, each with a test.</a:t>
+              <a:t>Over fourteen hundred automated checks run on every change: 912 on the API, 393 on the dashboard, 118 on the kiosk, 35 on the gateway, including money calculated to the pesewa against payslips we worked by hand, and database rules proved against a real PostgreSQL. Every phase went through four reviews, and each serious finding was handed to a sceptic told to refute it. The whole-system review found twenty real problems; three were serious; all twenty are fixed, each with a test.</a:t>
             </a:r>
             <a:endParaRPr lang="en-US" dirty="0"/>
           </a:p>
@@ -1309,7 +1309,7 @@
           <a:p>
             <a:r>
               <a:rPr lang="en-US" dirty="0"/>
-              <a:t>A guard proves they are present with their face, on a company device at the site. That proof becomes a worked shift. The shift becomes pay, calculated to Ghana's PAYE and SSNIT rules. A second person must approve the pay, and then it is locked so nobody, not even an administrator, can quietly change it. And every night, eleven rules hunt through the data for pay without presence.</a:t>
+              <a:t>A guard proves they are present with their face, on a company device at the site. That proof becomes a worked shift. The shift becomes pay, calculated to Ghana's PAYE and SSNIT rules. An administrator approves the pay, and the system asks for their password first; then it is locked so nobody, not even an administrator, can quietly change it. And every night, eleven rules hunt through the data for pay without presence.</a:t>
             </a:r>
             <a:endParaRPr lang="en-US" dirty="0"/>
           </a:p>
@@ -1485,7 +1485,7 @@
           <a:p>
             <a:r>
               <a:rPr lang="en-US" dirty="0"/>
-              <a:t>First: evidence is never edited. Punches, consent records, audit lines and locked pay runs are append-only in the database itself; a trigger rejects changes, so even an administrator cannot rewrite history. Second: nobody important acts alone. Approving pay, deciding a duplicate face, creating an administrator, each needs a second person, and the database checks it, not just the screen. Third: a rule never punishes anybody. Detection raises a question with evidence; a human answers it in writing, and the answer is audited.</a:t>
+              <a:t>First: evidence is never edited. Punches, consent records, audit lines and locked pay runs are append-only in the database itself; a trigger rejects changes, so even an administrator cannot rewrite history. Second: sensitive actions ask for a password. Any administrator can act alone, but approving pay, deciding a duplicate face or creating an administrator first asks for their own password, every action is written to the audit log with their name, and ghost detection still flags suspicious patterns. Third: a rule never punishes anybody. Detection raises a question with evidence; a human answers it in writing, and the answer is audited.</a:t>
             </a:r>
             <a:endParaRPr lang="en-US" dirty="0"/>
           </a:p>
@@ -2495,7 +2495,7 @@
                 <a:ea typeface="Calibri" pitchFamily="34" charset="-122"/>
                 <a:cs typeface="Calibri" pitchFamily="34" charset="-120"/>
               </a:rPr>
-              <a:t>Demo 3 · A second person, then the lock</a:t>
+              <a:t>Demo 3 · A password, then the lock</a:t>
             </a:r>
             <a:endParaRPr lang="en-US" sz="3200" dirty="0"/>
           </a:p>
@@ -2534,7 +2534,7 @@
                 <a:ea typeface="Calibri" pitchFamily="34" charset="-122"/>
                 <a:cs typeface="Calibri" pitchFamily="34" charset="-120"/>
               </a:rPr>
-              <a:t>The maker is never the checker, and the database enforces it</a:t>
+              <a:t>Approving asks for my own password, and the database locks the figures</a:t>
             </a:r>
             <a:endParaRPr lang="en-US" sz="1400" dirty="0"/>
           </a:p>
@@ -2640,7 +2640,7 @@
         <p:spPr>
           <a:xfrm>
             <a:off x="658368" y="2121408"/>
-            <a:ext cx="2203704" cy="384048"/>
+            <a:ext cx="2203704" cy="731520"/>
           </a:xfrm>
           <a:prstGeom prst="rect">
             <a:avLst/>
@@ -2664,7 +2664,7 @@
                 <a:ea typeface="Calibri" pitchFamily="34" charset="-122"/>
                 <a:cs typeface="Calibri" pitchFamily="34" charset="-120"/>
               </a:rPr>
-              <a:t>I prepared it</a:t>
+              <a:t>I prepared it, and I approve it</a:t>
             </a:r>
             <a:endParaRPr lang="en-US" sz="1600" dirty="0"/>
           </a:p>
@@ -2678,8 +2678,8 @@
         </p:nvSpPr>
         <p:spPr>
           <a:xfrm>
-            <a:off x="658368" y="2505456"/>
-            <a:ext cx="2203704" cy="1773936"/>
+            <a:off x="658368" y="2852928"/>
+            <a:ext cx="2203704" cy="1426464"/>
           </a:xfrm>
           <a:prstGeom prst="rect">
             <a:avLst/>
@@ -2703,7 +2703,7 @@
                 <a:ea typeface="Calibri" pitchFamily="34" charset="-122"/>
                 <a:cs typeface="Calibri" pitchFamily="34" charset="-120"/>
               </a:rPr>
-              <a:t>So the system refuses to let me approve it. If it refuses on stage, that is the feature working.</a:t>
+              <a:t>One administrator may do both. The system asks for my own password first: if it asks on stage, that is the feature working.</a:t>
             </a:r>
             <a:endParaRPr lang="en-US" sz="1250" dirty="0"/>
           </a:p>
@@ -2833,7 +2833,7 @@
                 <a:ea typeface="Calibri" pitchFamily="34" charset="-122"/>
                 <a:cs typeface="Calibri" pitchFamily="34" charset="-120"/>
               </a:rPr>
-              <a:t>A different person approves</a:t>
+              <a:t>My password, written down</a:t>
             </a:r>
             <a:endParaRPr lang="en-US" sz="1600" dirty="0"/>
           </a:p>
@@ -2872,7 +2872,7 @@
                 <a:ea typeface="Calibri" pitchFamily="34" charset="-122"/>
                 <a:cs typeface="Calibri" pitchFamily="34" charset="-120"/>
               </a:rPr>
-              <a:t>A second account, with its own password and two-factor code. The database checks the two names differ; the screen alone could be bypassed.</a:t>
+              <a:t>The confirmation is good for five minutes and lands in the audit log with my name. Eleven detection rules still watch the pay for suspicious patterns.</a:t>
             </a:r>
             <a:endParaRPr lang="en-US" sz="1250" dirty="0"/>
           </a:p>
@@ -4362,7 +4362,7 @@
                 <a:ea typeface="Calibri" pitchFamily="34" charset="-122"/>
                 <a:cs typeface="Calibri" pitchFamily="34" charset="-120"/>
               </a:rPr>
-              <a:t>897</a:t>
+              <a:t>912</a:t>
             </a:r>
             <a:endParaRPr lang="en-US" sz="4000" dirty="0"/>
           </a:p>
@@ -4440,7 +4440,7 @@
                 <a:ea typeface="Calibri" pitchFamily="34" charset="-122"/>
                 <a:cs typeface="Calibri" pitchFamily="34" charset="-120"/>
               </a:rPr>
-              <a:t>383</a:t>
+              <a:t>393</a:t>
             </a:r>
             <a:endParaRPr lang="en-US" sz="4000" dirty="0"/>
           </a:p>
@@ -4518,7 +4518,7 @@
                 <a:ea typeface="Calibri" pitchFamily="34" charset="-122"/>
                 <a:cs typeface="Calibri" pitchFamily="34" charset="-120"/>
               </a:rPr>
-              <a:t>106</a:t>
+              <a:t>118</a:t>
             </a:r>
             <a:endParaRPr lang="en-US" sz="4000" dirty="0"/>
           </a:p>
@@ -7800,7 +7800,7 @@
                 <a:ea typeface="Calibri" pitchFamily="34" charset="-122"/>
                 <a:cs typeface="Calibri" pitchFamily="34" charset="-120"/>
               </a:rPr>
-              <a:t>Second person approves</a:t>
+              <a:t>Approved with a password</a:t>
             </a:r>
             <a:endParaRPr lang="en-US" sz="1250" dirty="0"/>
           </a:p>
@@ -7995,7 +7995,7 @@
                 <a:ea typeface="Calibri" pitchFamily="34" charset="-122"/>
                 <a:cs typeface="Calibri" pitchFamily="34" charset="-120"/>
               </a:rPr>
-              <a:t>A guard proves presence with their face, on a company device at the site. That proof becomes a shift, the shift becomes pay, a second person approves it, and then nobody can quietly change it.</a:t>
+              <a:t>A guard proves presence with their face, on a company device at the site. That proof becomes a shift, the shift becomes pay, an administrator approves it with their own password, and then nobody can quietly change it.</a:t>
             </a:r>
             <a:endParaRPr lang="en-US" sz="1300" dirty="0"/>
           </a:p>
@@ -9153,7 +9153,7 @@
                 <a:ea typeface="Calibri" pitchFamily="34" charset="-122"/>
                 <a:cs typeface="Calibri" pitchFamily="34" charset="-120"/>
               </a:rPr>
-              <a:t>Nobody important acts alone</a:t>
+              <a:t>Sensitive actions ask for a password</a:t>
             </a:r>
             <a:endParaRPr lang="en-US" sz="1600" dirty="0"/>
           </a:p>
@@ -9192,7 +9192,7 @@
                 <a:ea typeface="Calibri" pitchFamily="34" charset="-122"/>
                 <a:cs typeface="Calibri" pitchFamily="34" charset="-120"/>
               </a:rPr>
-              <a:t>Approving pay, deciding a duplicate face, creating an administrator: each needs a second person. The database checks it, not just the screen.</a:t>
+              <a:t>Approving pay, deciding a duplicate face, creating an administrator: any administrator may, after confirming their own password. Every action is in the audit log, and detection watches the patterns.</a:t>
             </a:r>
             <a:endParaRPr lang="en-US" sz="1300" dirty="0"/>
           </a:p>

</xml_diff>

<commit_message>
docs: the defence deck's test numbers as of 4 October
API 920 (431 unit + 489 against a real database), dashboard 394, kiosk 156,
gateway 35: over fifteen hundred checks on every change.
</commit_message>
<xml_diff>
--- a/docs/guides/SAMTEC-defence-slides.pptx
+++ b/docs/guides/SAMTEC-defence-slides.pptx
@@ -781,7 +781,7 @@
           <a:p>
             <a:r>
               <a:rPr lang="en-US" dirty="0"/>
-              <a:t>Over fourteen hundred automated checks run on every change: 912 on the API, 393 on the dashboard, 118 on the kiosk, 35 on the gateway, including money calculated to the pesewa against payslips we worked by hand, and database rules proved against a real PostgreSQL. Every phase went through four reviews, and each serious finding was handed to a sceptic told to refute it. The whole-system review found twenty real problems; three were serious; all twenty are fixed, each with a test.</a:t>
+              <a:t>Over fifteen hundred automated checks run on every change: 920 on the API, 394 on the dashboard, 156 on the kiosk, 35 on the gateway, including money calculated to the pesewa against payslips we worked by hand, and database rules proved against a real PostgreSQL. Every phase went through four reviews, and each serious finding was handed to a sceptic told to refute it. The whole-system review found twenty real problems; three were serious; all twenty are fixed, each with a test.</a:t>
             </a:r>
             <a:endParaRPr lang="en-US" dirty="0"/>
           </a:p>
@@ -4362,7 +4362,7 @@
                 <a:ea typeface="Calibri" pitchFamily="34" charset="-122"/>
                 <a:cs typeface="Calibri" pitchFamily="34" charset="-120"/>
               </a:rPr>
-              <a:t>912</a:t>
+              <a:t>920</a:t>
             </a:r>
             <a:endParaRPr lang="en-US" sz="4000" dirty="0"/>
           </a:p>
@@ -4440,7 +4440,7 @@
                 <a:ea typeface="Calibri" pitchFamily="34" charset="-122"/>
                 <a:cs typeface="Calibri" pitchFamily="34" charset="-120"/>
               </a:rPr>
-              <a:t>393</a:t>
+              <a:t>394</a:t>
             </a:r>
             <a:endParaRPr lang="en-US" sz="4000" dirty="0"/>
           </a:p>
@@ -4518,7 +4518,7 @@
                 <a:ea typeface="Calibri" pitchFamily="34" charset="-122"/>
                 <a:cs typeface="Calibri" pitchFamily="34" charset="-120"/>
               </a:rPr>
-              <a:t>118</a:t>
+              <a:t>156</a:t>
             </a:r>
             <a:endParaRPr lang="en-US" sz="4000" dirty="0"/>
           </a:p>

</xml_diff>

<commit_message>
docs: the defence deck's test numbers as of 4 October (#115)
API 920 (431 unit + 489 against a real database), dashboard 394, kiosk 156,
gateway 35: over fifteen hundred checks on every change.

Co-authored-by: Samkim2468 <samkyei203@gmail.com>
</commit_message>
<xml_diff>
--- a/docs/guides/SAMTEC-defence-slides.pptx
+++ b/docs/guides/SAMTEC-defence-slides.pptx
@@ -781,7 +781,7 @@
           <a:p>
             <a:r>
               <a:rPr lang="en-US" dirty="0"/>
-              <a:t>Over fourteen hundred automated checks run on every change: 912 on the API, 393 on the dashboard, 118 on the kiosk, 35 on the gateway, including money calculated to the pesewa against payslips we worked by hand, and database rules proved against a real PostgreSQL. Every phase went through four reviews, and each serious finding was handed to a sceptic told to refute it. The whole-system review found twenty real problems; three were serious; all twenty are fixed, each with a test.</a:t>
+              <a:t>Over fifteen hundred automated checks run on every change: 920 on the API, 394 on the dashboard, 156 on the kiosk, 35 on the gateway, including money calculated to the pesewa against payslips we worked by hand, and database rules proved against a real PostgreSQL. Every phase went through four reviews, and each serious finding was handed to a sceptic told to refute it. The whole-system review found twenty real problems; three were serious; all twenty are fixed, each with a test.</a:t>
             </a:r>
             <a:endParaRPr lang="en-US" dirty="0"/>
           </a:p>
@@ -4362,7 +4362,7 @@
                 <a:ea typeface="Calibri" pitchFamily="34" charset="-122"/>
                 <a:cs typeface="Calibri" pitchFamily="34" charset="-120"/>
               </a:rPr>
-              <a:t>912</a:t>
+              <a:t>920</a:t>
             </a:r>
             <a:endParaRPr lang="en-US" sz="4000" dirty="0"/>
           </a:p>
@@ -4440,7 +4440,7 @@
                 <a:ea typeface="Calibri" pitchFamily="34" charset="-122"/>
                 <a:cs typeface="Calibri" pitchFamily="34" charset="-120"/>
               </a:rPr>
-              <a:t>393</a:t>
+              <a:t>394</a:t>
             </a:r>
             <a:endParaRPr lang="en-US" sz="4000" dirty="0"/>
           </a:p>
@@ -4518,7 +4518,7 @@
                 <a:ea typeface="Calibri" pitchFamily="34" charset="-122"/>
                 <a:cs typeface="Calibri" pitchFamily="34" charset="-120"/>
               </a:rPr>
-              <a:t>118</a:t>
+              <a:t>156</a:t>
             </a:r>
             <a:endParaRPr lang="en-US" sz="4000" dirty="0"/>
           </a:p>

</xml_diff>

<commit_message>
docs: current test numbers in the defence script and the deck
API 1,004 (475 unit, 529 database), dashboard 483, kiosk 167, gateway 35:
1,689 automated checks on every push.
</commit_message>
<xml_diff>
--- a/docs/guides/SAMTEC-defence-slides.pptx
+++ b/docs/guides/SAMTEC-defence-slides.pptx
@@ -18255,7 +18255,7 @@
                 </a:solidFill>
                 <a:latin typeface="Calibri"/>
               </a:rPr>
-              <a:t>920</a:t>
+              <a:t>1,004</a:t>
             </a:r>
           </a:p>
         </p:txBody>
@@ -18297,7 +18297,7 @@
                 </a:solidFill>
                 <a:latin typeface="Calibri"/>
               </a:rPr>
-              <a:t>API checks: 431 unit, 489 database</a:t>
+              <a:t>API checks: 475 unit, 529 database</a:t>
             </a:r>
           </a:p>
         </p:txBody>
@@ -18387,7 +18387,7 @@
                 </a:solidFill>
                 <a:latin typeface="Calibri"/>
               </a:rPr>
-              <a:t>394</a:t>
+              <a:t>483</a:t>
             </a:r>
           </a:p>
         </p:txBody>
@@ -18519,7 +18519,7 @@
                 </a:solidFill>
                 <a:latin typeface="Calibri"/>
               </a:rPr>
-              <a:t>156</a:t>
+              <a:t>167</a:t>
             </a:r>
           </a:p>
         </p:txBody>
@@ -18825,7 +18825,7 @@
                 </a:solidFill>
                 <a:latin typeface="Calibri"/>
               </a:rPr>
-              <a:t>•  1,505 automated checks run on every push: lint, contract, types, tests, build</a:t>
+              <a:t>•  1,689 automated checks run on every push: lint, contract, types, tests, build</a:t>
             </a:r>
           </a:p>
           <a:p>

</xml_diff>

<commit_message>
docs: kiosk checks are 170 after the cancel-path tests
</commit_message>
<xml_diff>
--- a/docs/guides/SAMTEC-defence-slides.pptx
+++ b/docs/guides/SAMTEC-defence-slides.pptx
@@ -18519,7 +18519,7 @@
                 </a:solidFill>
                 <a:latin typeface="Calibri"/>
               </a:rPr>
-              <a:t>167</a:t>
+              <a:t>170</a:t>
             </a:r>
           </a:p>
         </p:txBody>
@@ -18825,7 +18825,7 @@
                 </a:solidFill>
                 <a:latin typeface="Calibri"/>
               </a:rPr>
-              <a:t>•  1,689 automated checks run on every push: lint, contract, types, tests, build</a:t>
+              <a:t>•  1,692 automated checks run on every push: lint, contract, types, tests, build</a:t>
             </a:r>
           </a:p>
           <a:p>

</xml_diff>

<commit_message>
Current test numbers in the defence script and the deck (#126)
* docs: current test numbers in the defence script and the deck

API 1,004 (475 unit, 529 database), dashboard 483, kiosk 167, gateway 35:
1,689 automated checks on every push.

* docs: kiosk checks are 170 after the cancel-path tests

---------

Co-authored-by: Samkim2468 <samkyei203@gmail.com>
</commit_message>
<xml_diff>
--- a/docs/guides/SAMTEC-defence-slides.pptx
+++ b/docs/guides/SAMTEC-defence-slides.pptx
@@ -18255,7 +18255,7 @@
                 </a:solidFill>
                 <a:latin typeface="Calibri"/>
               </a:rPr>
-              <a:t>920</a:t>
+              <a:t>1,004</a:t>
             </a:r>
           </a:p>
         </p:txBody>
@@ -18297,7 +18297,7 @@
                 </a:solidFill>
                 <a:latin typeface="Calibri"/>
               </a:rPr>
-              <a:t>API checks: 431 unit, 489 database</a:t>
+              <a:t>API checks: 475 unit, 529 database</a:t>
             </a:r>
           </a:p>
         </p:txBody>
@@ -18387,7 +18387,7 @@
                 </a:solidFill>
                 <a:latin typeface="Calibri"/>
               </a:rPr>
-              <a:t>394</a:t>
+              <a:t>483</a:t>
             </a:r>
           </a:p>
         </p:txBody>
@@ -18519,7 +18519,7 @@
                 </a:solidFill>
                 <a:latin typeface="Calibri"/>
               </a:rPr>
-              <a:t>156</a:t>
+              <a:t>170</a:t>
             </a:r>
           </a:p>
         </p:txBody>
@@ -18825,7 +18825,7 @@
                 </a:solidFill>
                 <a:latin typeface="Calibri"/>
               </a:rPr>
-              <a:t>•  1,505 automated checks run on every push: lint, contract, types, tests, build</a:t>
+              <a:t>•  1,692 automated checks run on every push: lint, contract, types, tests, build</a:t>
             </a:r>
           </a:p>
           <a:p>

</xml_diff>